<commit_message>
docs(deck): name the engine, not the language
The deterministic part is now "the AfriPlan Engine": the AI model reads;
the Engine counts, checks and prices.

Co-Authored-By: Claude Opus 5.5 <noreply@anthropic.com>
</commit_message>
<xml_diff>
--- a/docs/presentation/AfriPlan_User_Guide.pptx
+++ b/docs/presentation/AfriPlan_User_Guide.pptx
@@ -125,24 +125,24 @@
   <p:extLst>
     <p:ext uri="{521415D9-36F7-43E2-AB2F-B90AF26B5E84}">
       <p14:sectionLst xmlns:p14="http://schemas.microsoft.com/office/powerpoint/2010/main">
-        <p14:section name="Introduction" id="{28b4e2e6-1252-e918-c1bd-ca6a6ee114fd}">
+        <p14:section name="Introduction" id="{f16dc9e0-3edf-cba0-030a-8d5bb26590ae}">
           <p14:sldIdLst>
             <p14:sldId id="256"/>
           </p14:sldIdLst>
         </p14:section>
-        <p14:section name="The problem" id="{cf0a15d6-309e-af33-dc76-b02b04b4411f}">
+        <p14:section name="The problem" id="{0f6e897f-02fb-3f1f-d08b-d8e0f3d3e877}">
           <p14:sldIdLst>
             <p14:sldId id="257"/>
           </p14:sldIdLst>
         </p14:section>
-        <p14:section name="How AfriPlan works" id="{50f26e2c-e84c-74f5-4397-c6903b1b5008}">
+        <p14:section name="How AfriPlan works" id="{dd33db64-627c-d1b7-c8be-852f29dede8c}">
           <p14:sldIdLst>
             <p14:sldId id="258"/>
             <p14:sldId id="259"/>
             <p14:sldId id="260"/>
           </p14:sldIdLst>
         </p14:section>
-        <p14:section name="Using the web app" id="{a5092956-c282-6664-7013-9c194ae49e23}">
+        <p14:section name="Using the web app" id="{75ade9fc-8749-9d20-6997-3a952e8d144c}">
           <p14:sldIdLst>
             <p14:sldId id="261"/>
             <p14:sldId id="262"/>
@@ -151,31 +151,31 @@
             <p14:sldId id="265"/>
           </p14:sldIdLst>
         </p14:section>
-        <p14:section name="The AI Operating System" id="{d29ad30e-7f2c-8f25-4d7a-f8f764423ee6}">
+        <p14:section name="The AI Operating System" id="{a4684649-aae3-6773-d9c5-40b649f508b8}">
           <p14:sldIdLst>
             <p14:sldId id="266"/>
             <p14:sldId id="267"/>
           </p14:sldIdLst>
         </p14:section>
-        <p14:section name="How accurate is it" id="{77be9611-d922-f5b0-164e-a9150a7c9e13}">
+        <p14:section name="How accurate is it" id="{fb01e8e2-10aa-ca32-f25f-0cdcb1f0d409}">
           <p14:sldIdLst>
             <p14:sldId id="268"/>
             <p14:sldId id="269"/>
             <p14:sldId id="270"/>
           </p14:sldIdLst>
         </p14:section>
-        <p14:section name="Value for consulting engineers" id="{a8819422-b9d9-dcc8-88e9-5539c8a8ca06}">
+        <p14:section name="Value for consulting engineers" id="{d6a2fa74-758d-773f-4f27-ca8e55129186}">
           <p14:sldIdLst>
             <p14:sldId id="271"/>
             <p14:sldId id="272"/>
           </p14:sldIdLst>
         </p14:section>
-        <p14:section name="Conclusion" id="{10bf35a1-65e0-7941-4bb2-5c3bbe5d4971}">
+        <p14:section name="Conclusion" id="{d1f3a8f5-10cb-d7fc-a238-75811472977c}">
           <p14:sldIdLst>
             <p14:sldId id="273"/>
           </p14:sldIdLst>
         </p14:section>
-        <p14:section name="References" id="{f1d0f891-bd3a-c925-2acb-7edbaf5d06c6}">
+        <p14:section name="References" id="{facbdc19-2b54-90d1-0a5a-7e10b4017b6c}">
           <p14:sldIdLst>
             <p14:sldId id="274"/>
           </p14:sldIdLst>
@@ -1377,7 +1377,7 @@
           <a:p>
             <a:r>
               <a:rPr lang="en-US" dirty="0"/>
-              <a:t>Open the project in your code editor (IDE) and tell the AI brain: estimate the project in your folder. Step 1 and step 3 are Python programming: it prepares every page and, at the end, checks every reading, combines the PDF and CAD readers and prices once. Only step 2 uses the AI brain, on a subscription. The result lands in AfriPlan_Output inside the project folder</a:t>
+              <a:t>Open the project in your code editor (IDE) and tell the AI brain: estimate the project in your folder. Step 1 and step 3 are the AfriPlan Engine: it prepares every page and, at the end, checks every reading, combines the PDF and CAD readers and prices once. Only step 2 uses the AI brain, on a subscription. The result lands in AfriPlan_Output inside the project folder</a:t>
             </a:r>
             <a:endParaRPr lang="en-US" dirty="0"/>
           </a:p>
@@ -6726,7 +6726,7 @@
                   <a:schemeClr val="accent1"/>
                 </a:solidFill>
               </a:rPr>
-              <a:t>Python programming</a:t>
+              <a:t>AfriPlan Engine</a:t>
             </a:r>
             <a:endParaRPr lang="en-US" sz="1200" dirty="0"/>
           </a:p>
@@ -7138,7 +7138,7 @@
                   <a:schemeClr val="accent1"/>
                 </a:solidFill>
               </a:rPr>
-              <a:t>Python programming</a:t>
+              <a:t>AfriPlan Engine</a:t>
             </a:r>
             <a:endParaRPr lang="en-US" sz="1200" dirty="0"/>
           </a:p>
@@ -18581,7 +18581,7 @@
                   <a:schemeClr val="accent1"/>
                 </a:solidFill>
               </a:rPr>
-              <a:t>The AI model is the eyes; Python programming is the brain — the AI never invents a quantity, a length or a rate.</a:t>
+              <a:t>The AI model reads; the AfriPlan Engine counts, checks and prices — the AI never invents a quantity, a length or a rate.</a:t>
             </a:r>
             <a:endParaRPr lang="en-US" sz="1500" dirty="0"/>
           </a:p>

</xml_diff>